<commit_message>
Add RQ2 and RQ3 model answers to prep pack; add backup slide on telling the channels apart
</commit_message>
<xml_diff>
--- a/Interview_Deck_draft.pptx
+++ b/Interview_Deck_draft.pptx
@@ -28,6 +28,7 @@
     <p:sldId id="273" r:id="rId27"/>
     <p:sldId id="274" r:id="rId28"/>
     <p:sldId id="275" r:id="rId29"/>
+    <p:sldId id="276" r:id="rId30"/>
   </p:sldIdLst>
   <p:sldSz cx="12191695" cy="6858000"/>
   <p:notesSz cx="6858000" cy="9144000"/>
@@ -849,6 +850,65 @@
 </file>
 
 <file path=ppt/notesSlides/notesSlide20.xml><?xml version="1.0" encoding="utf-8"?>
+<p:notes xmlns:a="http://schemas.openxmlformats.org/drawingml/2006/main" xmlns:r="http://schemas.openxmlformats.org/officeDocument/2006/relationships" xmlns:p="http://schemas.openxmlformats.org/presentationml/2006/main">
+  <p:cSld>
+    <p:spTree>
+      <p:nvGrpSpPr>
+        <p:cNvPr id="1" name=""/>
+        <p:cNvGrpSpPr/>
+        <p:nvPr/>
+      </p:nvGrpSpPr>
+      <p:grpSpPr>
+        <a:xfrm>
+          <a:off x="0" y="0"/>
+          <a:ext cx="0" cy="0"/>
+          <a:chOff x="0" y="0"/>
+          <a:chExt cx="0" cy="0"/>
+        </a:xfrm>
+      </p:grpSpPr>
+      <p:sp>
+        <p:nvSpPr>
+          <p:cNvPr id="2" name="Slide Image Placeholder 1"/>
+          <p:cNvSpPr>
+            <a:spLocks noGrp="1" noRot="1" noChangeAspect="1"/>
+          </p:cNvSpPr>
+          <p:nvPr>
+            <p:ph type="sldImg"/>
+          </p:nvPr>
+        </p:nvSpPr>
+        <p:spPr/>
+      </p:sp>
+      <p:sp>
+        <p:nvSpPr>
+          <p:cNvPr id="3" name="Notes Placeholder 2"/>
+          <p:cNvSpPr>
+            <a:spLocks noGrp="1"/>
+          </p:cNvSpPr>
+          <p:nvPr>
+            <p:ph type="body" idx="1"/>
+          </p:nvPr>
+        </p:nvSpPr>
+        <p:spPr/>
+        <p:txBody>
+          <a:bodyPr/>
+          <a:lstStyle/>
+          <a:p>
+            <a:r>
+              <a:rPr lang="en-GB" sz="1200" dirty="0"/>
+              <a:t>See RQ3 in Interview_Preparation.md, Section 6, 'Answering the research questions directly'.</a:t>
+            </a:r>
+          </a:p>
+        </p:txBody>
+      </p:sp>
+    </p:spTree>
+  </p:cSld>
+  <p:clrMapOvr>
+    <a:masterClrMapping/>
+  </p:clrMapOvr>
+</p:notes>
+</file>
+
+<file path=ppt/notesSlides/notesSlide21.xml><?xml version="1.0" encoding="utf-8"?>
 <p:notes xmlns:a="http://schemas.openxmlformats.org/drawingml/2006/main" xmlns:r="http://schemas.openxmlformats.org/officeDocument/2006/relationships" xmlns:p="http://schemas.openxmlformats.org/presentationml/2006/main">
   <p:cSld>
     <p:spTree>
@@ -8816,7 +8876,7 @@
                 <a:latin typeface="Arial"/>
                 <a:cs typeface="Arial"/>
               </a:rPr>
-              <a:t>Backup: budget at a glance</a:t>
+              <a:t>Backup: telling the channels apart</a:t>
             </a:r>
             <a:endParaRPr lang="en-GB" sz="3200"/>
           </a:p>
@@ -8865,6 +8925,1014 @@
                 <a:cs typeface="Arial"/>
               </a:rPr>
               <a:t>20</a:t>
+            </a:r>
+            <a:endParaRPr lang="en-GB" sz="1400"/>
+          </a:p>
+        </p:txBody>
+      </p:sp>
+      <p:sp>
+        <p:nvSpPr>
+          <p:cNvPr id="4" name="Shape 4"/>
+          <p:cNvSpPr/>
+          <p:nvPr/>
+        </p:nvSpPr>
+        <p:spPr>
+          <a:xfrm>
+            <a:off x="548640" y="6382512"/>
+            <a:ext cx="8229600" cy="329184"/>
+          </a:xfrm>
+          <a:prstGeom prst="rect">
+            <a:avLst/>
+          </a:prstGeom>
+          <a:noFill/>
+          <a:ln>
+            <a:noFill/>
+          </a:ln>
+        </p:spPr>
+        <p:txBody>
+          <a:bodyPr wrap="square" lIns="0" tIns="0" rIns="0" bIns="0" anchor="t" rtlCol="0">
+            <a:noAutofit/>
+          </a:bodyPr>
+          <a:lstStyle/>
+          <a:p>
+            <a:pPr algn="l">
+              <a:lnSpc>
+                <a:spcPct val="100000"/>
+              </a:lnSpc>
+              <a:spcAft>
+                <a:spcPts val="600"/>
+              </a:spcAft>
+              <a:buNone/>
+            </a:pPr>
+            <a:r>
+              <a:rPr lang="en-GB" sz="1200" b="0" i="0" dirty="0">
+                <a:solidFill>
+                  <a:srgbClr val="5F6B7A"/>
+                </a:solidFill>
+                <a:latin typeface="Arial"/>
+                <a:cs typeface="Arial"/>
+              </a:rPr>
+              <a:t>Chiseni | Wellcome Early-Career Award interview | 355277/Z/26/Z</a:t>
+            </a:r>
+            <a:endParaRPr lang="en-GB" sz="1200"/>
+          </a:p>
+        </p:txBody>
+      </p:sp>
+      <p:sp>
+        <p:nvSpPr>
+          <p:cNvPr id="5" name="Shape 5"/>
+          <p:cNvSpPr/>
+          <p:nvPr/>
+        </p:nvSpPr>
+        <p:spPr>
+          <a:xfrm>
+            <a:off x="548640" y="1463040"/>
+            <a:ext cx="1188720" cy="64008"/>
+          </a:xfrm>
+          <a:prstGeom prst="rect">
+            <a:avLst/>
+          </a:prstGeom>
+          <a:solidFill>
+            <a:srgbClr val="0072B2"/>
+          </a:solidFill>
+          <a:ln>
+            <a:noFill/>
+          </a:ln>
+        </p:spPr>
+        <p:txBody>
+          <a:bodyPr wrap="square" lIns="91440" tIns="45720" rIns="91440" bIns="45720" anchor="t" rtlCol="0">
+            <a:noAutofit/>
+          </a:bodyPr>
+          <a:lstStyle/>
+          <a:p>
+            <a:endParaRPr lang="en-GB" sz="1200"/>
+          </a:p>
+        </p:txBody>
+      </p:sp>
+      <p:sp>
+        <p:nvSpPr>
+          <p:cNvPr id="6" name="Shape 6"/>
+          <p:cNvSpPr/>
+          <p:nvPr/>
+        </p:nvSpPr>
+        <p:spPr>
+          <a:xfrm>
+            <a:off x="548640" y="1691640"/>
+            <a:ext cx="2514600" cy="548640"/>
+          </a:xfrm>
+          <a:prstGeom prst="rect">
+            <a:avLst/>
+          </a:prstGeom>
+          <a:solidFill>
+            <a:srgbClr val="1F2A44"/>
+          </a:solidFill>
+          <a:ln>
+            <a:noFill/>
+          </a:ln>
+        </p:spPr>
+        <p:txBody>
+          <a:bodyPr wrap="square" lIns="109728" tIns="54864" rIns="109728" bIns="54864" anchor="ctr" rtlCol="0">
+            <a:noAutofit/>
+          </a:bodyPr>
+          <a:lstStyle/>
+          <a:p>
+            <a:pPr algn="l">
+              <a:lnSpc>
+                <a:spcPct val="100000"/>
+              </a:lnSpc>
+              <a:spcAft>
+                <a:spcPts val="600"/>
+              </a:spcAft>
+              <a:buNone/>
+            </a:pPr>
+            <a:r>
+              <a:rPr lang="en-GB" sz="2000" b="1" i="0" dirty="0">
+                <a:solidFill>
+                  <a:srgbClr val="FFFFFF"/>
+                </a:solidFill>
+                <a:latin typeface="Arial"/>
+                <a:cs typeface="Arial"/>
+              </a:rPr>
+              <a:t>Channel</a:t>
+            </a:r>
+            <a:endParaRPr lang="en-GB" sz="2000"/>
+          </a:p>
+        </p:txBody>
+      </p:sp>
+      <p:sp>
+        <p:nvSpPr>
+          <p:cNvPr id="7" name="Shape 7"/>
+          <p:cNvSpPr/>
+          <p:nvPr/>
+        </p:nvSpPr>
+        <p:spPr>
+          <a:xfrm>
+            <a:off x="3118104" y="1691640"/>
+            <a:ext cx="4206240" cy="548640"/>
+          </a:xfrm>
+          <a:prstGeom prst="rect">
+            <a:avLst/>
+          </a:prstGeom>
+          <a:solidFill>
+            <a:srgbClr val="1F2A44"/>
+          </a:solidFill>
+          <a:ln>
+            <a:noFill/>
+          </a:ln>
+        </p:spPr>
+        <p:txBody>
+          <a:bodyPr wrap="square" lIns="109728" tIns="54864" rIns="109728" bIns="54864" anchor="ctr" rtlCol="0">
+            <a:noAutofit/>
+          </a:bodyPr>
+          <a:lstStyle/>
+          <a:p>
+            <a:pPr algn="l">
+              <a:lnSpc>
+                <a:spcPct val="100000"/>
+              </a:lnSpc>
+              <a:spcAft>
+                <a:spcPts val="600"/>
+              </a:spcAft>
+              <a:buNone/>
+            </a:pPr>
+            <a:r>
+              <a:rPr lang="en-GB" sz="2000" b="1" i="0" dirty="0">
+                <a:solidFill>
+                  <a:srgbClr val="FFFFFF"/>
+                </a:solidFill>
+                <a:latin typeface="Arial"/>
+                <a:cs typeface="Arial"/>
+              </a:rPr>
+              <a:t>What you'd see</a:t>
+            </a:r>
+            <a:endParaRPr lang="en-GB" sz="2000"/>
+          </a:p>
+        </p:txBody>
+      </p:sp>
+      <p:sp>
+        <p:nvSpPr>
+          <p:cNvPr id="8" name="Shape 8"/>
+          <p:cNvSpPr/>
+          <p:nvPr/>
+        </p:nvSpPr>
+        <p:spPr>
+          <a:xfrm>
+            <a:off x="7379208" y="1691640"/>
+            <a:ext cx="4261104" cy="548640"/>
+          </a:xfrm>
+          <a:prstGeom prst="rect">
+            <a:avLst/>
+          </a:prstGeom>
+          <a:solidFill>
+            <a:srgbClr val="1F2A44"/>
+          </a:solidFill>
+          <a:ln>
+            <a:noFill/>
+          </a:ln>
+        </p:spPr>
+        <p:txBody>
+          <a:bodyPr wrap="square" lIns="109728" tIns="54864" rIns="109728" bIns="54864" anchor="ctr" rtlCol="0">
+            <a:noAutofit/>
+          </a:bodyPr>
+          <a:lstStyle/>
+          <a:p>
+            <a:pPr algn="l">
+              <a:lnSpc>
+                <a:spcPct val="100000"/>
+              </a:lnSpc>
+              <a:spcAft>
+                <a:spcPts val="600"/>
+              </a:spcAft>
+              <a:buNone/>
+            </a:pPr>
+            <a:r>
+              <a:rPr lang="en-GB" sz="2000" b="1" i="0" dirty="0">
+                <a:solidFill>
+                  <a:srgbClr val="FFFFFF"/>
+                </a:solidFill>
+                <a:latin typeface="Arial"/>
+                <a:cs typeface="Arial"/>
+              </a:rPr>
+              <a:t>Main evidence</a:t>
+            </a:r>
+            <a:endParaRPr lang="en-GB" sz="2000"/>
+          </a:p>
+        </p:txBody>
+      </p:sp>
+      <p:sp>
+        <p:nvSpPr>
+          <p:cNvPr id="9" name="Shape 9"/>
+          <p:cNvSpPr/>
+          <p:nvPr/>
+        </p:nvSpPr>
+        <p:spPr>
+          <a:xfrm>
+            <a:off x="548640" y="2295144"/>
+            <a:ext cx="2514600" cy="868680"/>
+          </a:xfrm>
+          <a:prstGeom prst="rect">
+            <a:avLst/>
+          </a:prstGeom>
+          <a:solidFill>
+            <a:srgbClr val="EEF1F5"/>
+          </a:solidFill>
+          <a:ln>
+            <a:noFill/>
+          </a:ln>
+        </p:spPr>
+        <p:txBody>
+          <a:bodyPr wrap="square" lIns="109728" tIns="54864" rIns="109728" bIns="54864" anchor="ctr" rtlCol="0">
+            <a:noAutofit/>
+          </a:bodyPr>
+          <a:lstStyle/>
+          <a:p>
+            <a:pPr algn="l">
+              <a:lnSpc>
+                <a:spcPct val="100000"/>
+              </a:lnSpc>
+              <a:spcAft>
+                <a:spcPts val="600"/>
+              </a:spcAft>
+              <a:buNone/>
+            </a:pPr>
+            <a:r>
+              <a:rPr lang="en-GB" sz="1800" b="1" i="0" dirty="0">
+                <a:solidFill>
+                  <a:srgbClr val="1F2A44"/>
+                </a:solidFill>
+                <a:latin typeface="Arial"/>
+                <a:cs typeface="Arial"/>
+              </a:rPr>
+              <a:t>Surviving faith-based facilities</a:t>
+            </a:r>
+            <a:endParaRPr lang="en-GB" sz="1800"/>
+          </a:p>
+        </p:txBody>
+      </p:sp>
+      <p:sp>
+        <p:nvSpPr>
+          <p:cNvPr id="10" name="Shape 10"/>
+          <p:cNvSpPr/>
+          <p:nvPr/>
+        </p:nvSpPr>
+        <p:spPr>
+          <a:xfrm>
+            <a:off x="3118104" y="2295144"/>
+            <a:ext cx="4206240" cy="868680"/>
+          </a:xfrm>
+          <a:prstGeom prst="rect">
+            <a:avLst/>
+          </a:prstGeom>
+          <a:solidFill>
+            <a:srgbClr val="EEF1F5"/>
+          </a:solidFill>
+          <a:ln>
+            <a:noFill/>
+          </a:ln>
+        </p:spPr>
+        <p:txBody>
+          <a:bodyPr wrap="square" lIns="109728" tIns="54864" rIns="109728" bIns="54864" anchor="ctr" rtlCol="0">
+            <a:noAutofit/>
+          </a:bodyPr>
+          <a:lstStyle/>
+          <a:p>
+            <a:pPr algn="l">
+              <a:lnSpc>
+                <a:spcPct val="100000"/>
+              </a:lnSpc>
+              <a:spcAft>
+                <a:spcPts val="600"/>
+              </a:spcAft>
+              <a:buNone/>
+            </a:pPr>
+            <a:r>
+              <a:rPr lang="en-GB" sz="1800" b="0" i="0" dirty="0">
+                <a:solidFill>
+                  <a:srgbClr val="1F2A44"/>
+                </a:solidFill>
+                <a:latin typeface="Arial"/>
+                <a:cs typeface="Arial"/>
+              </a:rPr>
+              <a:t>Effect concentrated where the mission facility still runs</a:t>
+            </a:r>
+            <a:endParaRPr lang="en-GB" sz="1800"/>
+          </a:p>
+        </p:txBody>
+      </p:sp>
+      <p:sp>
+        <p:nvSpPr>
+          <p:cNvPr id="11" name="Shape 11"/>
+          <p:cNvSpPr/>
+          <p:nvPr/>
+        </p:nvSpPr>
+        <p:spPr>
+          <a:xfrm>
+            <a:off x="7379208" y="2295144"/>
+            <a:ext cx="4261104" cy="868680"/>
+          </a:xfrm>
+          <a:prstGeom prst="rect">
+            <a:avLst/>
+          </a:prstGeom>
+          <a:solidFill>
+            <a:srgbClr val="EEF1F5"/>
+          </a:solidFill>
+          <a:ln>
+            <a:noFill/>
+          </a:ln>
+        </p:spPr>
+        <p:txBody>
+          <a:bodyPr wrap="square" lIns="109728" tIns="54864" rIns="109728" bIns="54864" anchor="ctr" rtlCol="0">
+            <a:noAutofit/>
+          </a:bodyPr>
+          <a:lstStyle/>
+          <a:p>
+            <a:pPr algn="l">
+              <a:lnSpc>
+                <a:spcPct val="100000"/>
+              </a:lnSpc>
+              <a:spcAft>
+                <a:spcPts val="600"/>
+              </a:spcAft>
+              <a:buNone/>
+            </a:pPr>
+            <a:r>
+              <a:rPr lang="en-GB" sz="1800" b="0" i="0" dirty="0">
+                <a:solidFill>
+                  <a:srgbClr val="1F2A44"/>
+                </a:solidFill>
+                <a:latin typeface="Arial"/>
+                <a:cs typeface="Arial"/>
+              </a:rPr>
+              <a:t>KEMRI-WHO faith-based flag; CHAZ list; DHS place of delivery</a:t>
+            </a:r>
+            <a:endParaRPr lang="en-GB" sz="1800"/>
+          </a:p>
+        </p:txBody>
+      </p:sp>
+      <p:sp>
+        <p:nvSpPr>
+          <p:cNvPr id="12" name="Shape 12"/>
+          <p:cNvSpPr/>
+          <p:nvPr/>
+        </p:nvSpPr>
+        <p:spPr>
+          <a:xfrm>
+            <a:off x="548640" y="3218688"/>
+            <a:ext cx="2514600" cy="868680"/>
+          </a:xfrm>
+          <a:prstGeom prst="rect">
+            <a:avLst/>
+          </a:prstGeom>
+          <a:solidFill>
+            <a:srgbClr val="EEF1F5"/>
+          </a:solidFill>
+          <a:ln>
+            <a:noFill/>
+          </a:ln>
+        </p:spPr>
+        <p:txBody>
+          <a:bodyPr wrap="square" lIns="109728" tIns="54864" rIns="109728" bIns="54864" anchor="ctr" rtlCol="0">
+            <a:noAutofit/>
+          </a:bodyPr>
+          <a:lstStyle/>
+          <a:p>
+            <a:pPr algn="l">
+              <a:lnSpc>
+                <a:spcPct val="100000"/>
+              </a:lnSpc>
+              <a:spcAft>
+                <a:spcPts val="600"/>
+              </a:spcAft>
+              <a:buNone/>
+            </a:pPr>
+            <a:r>
+              <a:rPr lang="en-GB" sz="1800" b="1" i="0" dirty="0">
+                <a:solidFill>
+                  <a:srgbClr val="1F2A44"/>
+                </a:solidFill>
+                <a:latin typeface="Arial"/>
+                <a:cs typeface="Arial"/>
+              </a:rPr>
+              <a:t>Health-worker norms</a:t>
+            </a:r>
+            <a:endParaRPr lang="en-GB" sz="1800"/>
+          </a:p>
+        </p:txBody>
+      </p:sp>
+      <p:sp>
+        <p:nvSpPr>
+          <p:cNvPr id="13" name="Shape 13"/>
+          <p:cNvSpPr/>
+          <p:nvPr/>
+        </p:nvSpPr>
+        <p:spPr>
+          <a:xfrm>
+            <a:off x="3118104" y="3218688"/>
+            <a:ext cx="4206240" cy="868680"/>
+          </a:xfrm>
+          <a:prstGeom prst="rect">
+            <a:avLst/>
+          </a:prstGeom>
+          <a:solidFill>
+            <a:srgbClr val="EEF1F5"/>
+          </a:solidFill>
+          <a:ln>
+            <a:noFill/>
+          </a:ln>
+        </p:spPr>
+        <p:txBody>
+          <a:bodyPr wrap="square" lIns="109728" tIns="54864" rIns="109728" bIns="54864" anchor="ctr" rtlCol="0">
+            <a:noAutofit/>
+          </a:bodyPr>
+          <a:lstStyle/>
+          <a:p>
+            <a:pPr algn="l">
+              <a:lnSpc>
+                <a:spcPct val="100000"/>
+              </a:lnSpc>
+              <a:spcAft>
+                <a:spcPts val="600"/>
+              </a:spcAft>
+              <a:buNone/>
+            </a:pPr>
+            <a:r>
+              <a:rPr lang="en-GB" sz="1800" b="0" i="0" dirty="0">
+                <a:solidFill>
+                  <a:srgbClr val="1F2A44"/>
+                </a:solidFill>
+                <a:latin typeface="Arial"/>
+                <a:cs typeface="Arial"/>
+              </a:rPr>
+              <a:t>Survives closure; better care at government clinics</a:t>
+            </a:r>
+            <a:endParaRPr lang="en-GB" sz="1800"/>
+          </a:p>
+        </p:txBody>
+      </p:sp>
+      <p:sp>
+        <p:nvSpPr>
+          <p:cNvPr id="14" name="Shape 14"/>
+          <p:cNvSpPr/>
+          <p:nvPr/>
+        </p:nvSpPr>
+        <p:spPr>
+          <a:xfrm>
+            <a:off x="7379208" y="3218688"/>
+            <a:ext cx="4261104" cy="868680"/>
+          </a:xfrm>
+          <a:prstGeom prst="rect">
+            <a:avLst/>
+          </a:prstGeom>
+          <a:solidFill>
+            <a:srgbClr val="EEF1F5"/>
+          </a:solidFill>
+          <a:ln>
+            <a:noFill/>
+          </a:ln>
+        </p:spPr>
+        <p:txBody>
+          <a:bodyPr wrap="square" lIns="109728" tIns="54864" rIns="109728" bIns="54864" anchor="ctr" rtlCol="0">
+            <a:noAutofit/>
+          </a:bodyPr>
+          <a:lstStyle/>
+          <a:p>
+            <a:pPr algn="l">
+              <a:lnSpc>
+                <a:spcPct val="100000"/>
+              </a:lnSpc>
+              <a:spcAft>
+                <a:spcPts val="600"/>
+              </a:spcAft>
+              <a:buNone/>
+            </a:pPr>
+            <a:r>
+              <a:rPr lang="en-GB" sz="1800" b="0" i="0" dirty="0">
+                <a:solidFill>
+                  <a:srgbClr val="1F2A44"/>
+                </a:solidFill>
+                <a:latin typeface="Arial"/>
+                <a:cs typeface="Arial"/>
+              </a:rPr>
+              <a:t>Training records; Afrobarometer clinic experience; life histories</a:t>
+            </a:r>
+            <a:endParaRPr lang="en-GB" sz="1800"/>
+          </a:p>
+        </p:txBody>
+      </p:sp>
+      <p:sp>
+        <p:nvSpPr>
+          <p:cNvPr id="15" name="Shape 15"/>
+          <p:cNvSpPr/>
+          <p:nvPr/>
+        </p:nvSpPr>
+        <p:spPr>
+          <a:xfrm>
+            <a:off x="548640" y="4142232"/>
+            <a:ext cx="2514600" cy="868680"/>
+          </a:xfrm>
+          <a:prstGeom prst="rect">
+            <a:avLst/>
+          </a:prstGeom>
+          <a:solidFill>
+            <a:srgbClr val="EEF1F5"/>
+          </a:solidFill>
+          <a:ln>
+            <a:noFill/>
+          </a:ln>
+        </p:spPr>
+        <p:txBody>
+          <a:bodyPr wrap="square" lIns="109728" tIns="54864" rIns="109728" bIns="54864" anchor="ctr" rtlCol="0">
+            <a:noAutofit/>
+          </a:bodyPr>
+          <a:lstStyle/>
+          <a:p>
+            <a:pPr algn="l">
+              <a:lnSpc>
+                <a:spcPct val="100000"/>
+              </a:lnSpc>
+              <a:spcAft>
+                <a:spcPts val="600"/>
+              </a:spcAft>
+              <a:buNone/>
+            </a:pPr>
+            <a:r>
+              <a:rPr lang="en-GB" sz="1800" b="1" i="0" dirty="0">
+                <a:solidFill>
+                  <a:srgbClr val="1F2A44"/>
+                </a:solidFill>
+                <a:latin typeface="Arial"/>
+                <a:cs typeface="Arial"/>
+              </a:rPr>
+              <a:t>Religious norm</a:t>
+            </a:r>
+            <a:endParaRPr lang="en-GB" sz="1800"/>
+          </a:p>
+        </p:txBody>
+      </p:sp>
+      <p:sp>
+        <p:nvSpPr>
+          <p:cNvPr id="16" name="Shape 16"/>
+          <p:cNvSpPr/>
+          <p:nvPr/>
+        </p:nvSpPr>
+        <p:spPr>
+          <a:xfrm>
+            <a:off x="3118104" y="4142232"/>
+            <a:ext cx="4206240" cy="868680"/>
+          </a:xfrm>
+          <a:prstGeom prst="rect">
+            <a:avLst/>
+          </a:prstGeom>
+          <a:solidFill>
+            <a:srgbClr val="EEF1F5"/>
+          </a:solidFill>
+          <a:ln>
+            <a:noFill/>
+          </a:ln>
+        </p:spPr>
+        <p:txBody>
+          <a:bodyPr wrap="square" lIns="109728" tIns="54864" rIns="109728" bIns="54864" anchor="ctr" rtlCol="0">
+            <a:noAutofit/>
+          </a:bodyPr>
+          <a:lstStyle/>
+          <a:p>
+            <a:pPr algn="l">
+              <a:lnSpc>
+                <a:spcPct val="100000"/>
+              </a:lnSpc>
+              <a:spcAft>
+                <a:spcPts val="600"/>
+              </a:spcAft>
+              <a:buNone/>
+            </a:pPr>
+            <a:r>
+              <a:rPr lang="en-GB" sz="1800" b="0" i="0" dirty="0">
+                <a:solidFill>
+                  <a:srgbClr val="1F2A44"/>
+                </a:solidFill>
+                <a:latin typeface="Arial"/>
+                <a:cs typeface="Arial"/>
+              </a:rPr>
+              <a:t>Strongest among members of the mission's church</a:t>
+            </a:r>
+            <a:endParaRPr lang="en-GB" sz="1800"/>
+          </a:p>
+        </p:txBody>
+      </p:sp>
+      <p:sp>
+        <p:nvSpPr>
+          <p:cNvPr id="17" name="Shape 17"/>
+          <p:cNvSpPr/>
+          <p:nvPr/>
+        </p:nvSpPr>
+        <p:spPr>
+          <a:xfrm>
+            <a:off x="7379208" y="4142232"/>
+            <a:ext cx="4261104" cy="868680"/>
+          </a:xfrm>
+          <a:prstGeom prst="rect">
+            <a:avLst/>
+          </a:prstGeom>
+          <a:solidFill>
+            <a:srgbClr val="EEF1F5"/>
+          </a:solidFill>
+          <a:ln>
+            <a:noFill/>
+          </a:ln>
+        </p:spPr>
+        <p:txBody>
+          <a:bodyPr wrap="square" lIns="109728" tIns="54864" rIns="109728" bIns="54864" anchor="ctr" rtlCol="0">
+            <a:noAutofit/>
+          </a:bodyPr>
+          <a:lstStyle/>
+          <a:p>
+            <a:pPr algn="l">
+              <a:lnSpc>
+                <a:spcPct val="100000"/>
+              </a:lnSpc>
+              <a:spcAft>
+                <a:spcPts val="600"/>
+              </a:spcAft>
+              <a:buNone/>
+            </a:pPr>
+            <a:r>
+              <a:rPr lang="en-GB" sz="1800" b="0" i="0" dirty="0">
+                <a:solidFill>
+                  <a:srgbClr val="1F2A44"/>
+                </a:solidFill>
+                <a:latin typeface="Arial"/>
+                <a:cs typeface="Arial"/>
+              </a:rPr>
+              <a:t>Religion in DHS and Afrobarometer; church teaching</a:t>
+            </a:r>
+            <a:endParaRPr lang="en-GB" sz="1800"/>
+          </a:p>
+        </p:txBody>
+      </p:sp>
+      <p:sp>
+        <p:nvSpPr>
+          <p:cNvPr id="18" name="Shape 18"/>
+          <p:cNvSpPr/>
+          <p:nvPr/>
+        </p:nvSpPr>
+        <p:spPr>
+          <a:xfrm>
+            <a:off x="548640" y="5065776"/>
+            <a:ext cx="2514600" cy="868680"/>
+          </a:xfrm>
+          <a:prstGeom prst="rect">
+            <a:avLst/>
+          </a:prstGeom>
+          <a:solidFill>
+            <a:srgbClr val="EEF1F5"/>
+          </a:solidFill>
+          <a:ln>
+            <a:noFill/>
+          </a:ln>
+        </p:spPr>
+        <p:txBody>
+          <a:bodyPr wrap="square" lIns="109728" tIns="54864" rIns="109728" bIns="54864" anchor="ctr" rtlCol="0">
+            <a:noAutofit/>
+          </a:bodyPr>
+          <a:lstStyle/>
+          <a:p>
+            <a:pPr algn="l">
+              <a:lnSpc>
+                <a:spcPct val="100000"/>
+              </a:lnSpc>
+              <a:spcAft>
+                <a:spcPts val="600"/>
+              </a:spcAft>
+              <a:buNone/>
+            </a:pPr>
+            <a:r>
+              <a:rPr lang="en-GB" sz="1800" b="1" i="0" dirty="0">
+                <a:solidFill>
+                  <a:srgbClr val="1F2A44"/>
+                </a:solidFill>
+                <a:latin typeface="Arial"/>
+                <a:cs typeface="Arial"/>
+              </a:rPr>
+              <a:t>Coercion</a:t>
+            </a:r>
+            <a:endParaRPr lang="en-GB" sz="1800"/>
+          </a:p>
+        </p:txBody>
+      </p:sp>
+      <p:sp>
+        <p:nvSpPr>
+          <p:cNvPr id="19" name="Shape 19"/>
+          <p:cNvSpPr/>
+          <p:nvPr/>
+        </p:nvSpPr>
+        <p:spPr>
+          <a:xfrm>
+            <a:off x="3118104" y="5065776"/>
+            <a:ext cx="4206240" cy="868680"/>
+          </a:xfrm>
+          <a:prstGeom prst="rect">
+            <a:avLst/>
+          </a:prstGeom>
+          <a:solidFill>
+            <a:srgbClr val="EEF1F5"/>
+          </a:solidFill>
+          <a:ln>
+            <a:noFill/>
+          </a:ln>
+        </p:spPr>
+        <p:txBody>
+          <a:bodyPr wrap="square" lIns="109728" tIns="54864" rIns="109728" bIns="54864" anchor="ctr" rtlCol="0">
+            <a:noAutofit/>
+          </a:bodyPr>
+          <a:lstStyle/>
+          <a:p>
+            <a:pPr algn="l">
+              <a:lnSpc>
+                <a:spcPct val="100000"/>
+              </a:lnSpc>
+              <a:spcAft>
+                <a:spcPts val="600"/>
+              </a:spcAft>
+              <a:buNone/>
+            </a:pPr>
+            <a:r>
+              <a:rPr lang="en-GB" sz="1800" b="0" i="0" dirty="0">
+                <a:solidFill>
+                  <a:srgbClr val="1F2A44"/>
+                </a:solidFill>
+                <a:latin typeface="Arial"/>
+                <a:cs typeface="Arial"/>
+              </a:rPr>
+              <a:t>Deficit near leprosy settlements and campaigns; medicine only</a:t>
+            </a:r>
+            <a:endParaRPr lang="en-GB" sz="1800"/>
+          </a:p>
+        </p:txBody>
+      </p:sp>
+      <p:sp>
+        <p:nvSpPr>
+          <p:cNvPr id="20" name="Shape 20"/>
+          <p:cNvSpPr/>
+          <p:nvPr/>
+        </p:nvSpPr>
+        <p:spPr>
+          <a:xfrm>
+            <a:off x="7379208" y="5065776"/>
+            <a:ext cx="4261104" cy="868680"/>
+          </a:xfrm>
+          <a:prstGeom prst="rect">
+            <a:avLst/>
+          </a:prstGeom>
+          <a:solidFill>
+            <a:srgbClr val="EEF1F5"/>
+          </a:solidFill>
+          <a:ln>
+            <a:noFill/>
+          </a:ln>
+        </p:spPr>
+        <p:txBody>
+          <a:bodyPr wrap="square" lIns="109728" tIns="54864" rIns="109728" bIns="54864" anchor="ctr" rtlCol="0">
+            <a:noAutofit/>
+          </a:bodyPr>
+          <a:lstStyle/>
+          <a:p>
+            <a:pPr algn="l">
+              <a:lnSpc>
+                <a:spcPct val="100000"/>
+              </a:lnSpc>
+              <a:spcAft>
+                <a:spcPts val="600"/>
+              </a:spcAft>
+              <a:buNone/>
+            </a:pPr>
+            <a:r>
+              <a:rPr lang="en-GB" sz="1800" b="0" i="0" dirty="0">
+                <a:solidFill>
+                  <a:srgbClr val="1F2A44"/>
+                </a:solidFill>
+                <a:latin typeface="Arial"/>
+                <a:cs typeface="Arial"/>
+              </a:rPr>
+              <a:t>Archival coding; trust in police as placebo; memories</a:t>
+            </a:r>
+            <a:endParaRPr lang="en-GB" sz="1800"/>
+          </a:p>
+        </p:txBody>
+      </p:sp>
+      <p:sp>
+        <p:nvSpPr>
+          <p:cNvPr id="21" name="Shape 21"/>
+          <p:cNvSpPr/>
+          <p:nvPr/>
+        </p:nvSpPr>
+        <p:spPr>
+          <a:xfrm>
+            <a:off x="548640" y="5998464"/>
+            <a:ext cx="11094415" cy="365760"/>
+          </a:xfrm>
+          <a:prstGeom prst="rect">
+            <a:avLst/>
+          </a:prstGeom>
+          <a:noFill/>
+          <a:ln>
+            <a:noFill/>
+          </a:ln>
+        </p:spPr>
+        <p:txBody>
+          <a:bodyPr wrap="square" lIns="0" tIns="0" rIns="0" bIns="0" anchor="t" rtlCol="0">
+            <a:noAutofit/>
+          </a:bodyPr>
+          <a:lstStyle/>
+          <a:p>
+            <a:pPr algn="l">
+              <a:lnSpc>
+                <a:spcPct val="100000"/>
+              </a:lnSpc>
+              <a:spcAft>
+                <a:spcPts val="600"/>
+              </a:spcAft>
+              <a:buNone/>
+            </a:pPr>
+            <a:r>
+              <a:rPr lang="en-GB" sz="1400" b="0" i="0" dirty="0">
+                <a:solidFill>
+                  <a:srgbClr val="5F6B7A"/>
+                </a:solidFill>
+                <a:latin typeface="Arial"/>
+                <a:cs typeface="Arial"/>
+              </a:rPr>
+              <a:t>The surveys show where the effect appears; the fieldwork shows why.</a:t>
+            </a:r>
+            <a:endParaRPr lang="en-GB" sz="1400"/>
+          </a:p>
+        </p:txBody>
+      </p:sp>
+    </p:spTree>
+  </p:cSld>
+  <p:clrMapOvr>
+    <a:masterClrMapping/>
+  </p:clrMapOvr>
+</p:sld>
+</file>
+
+<file path=ppt/slides/slide21.xml><?xml version="1.0" encoding="utf-8"?>
+<p:sld xmlns:a="http://schemas.openxmlformats.org/drawingml/2006/main" xmlns:r="http://schemas.openxmlformats.org/officeDocument/2006/relationships" xmlns:p="http://schemas.openxmlformats.org/presentationml/2006/main">
+  <p:cSld>
+    <p:bg>
+      <p:bgPr>
+        <a:solidFill>
+          <a:srgbClr val="FFFFFF"/>
+        </a:solidFill>
+        <a:effectLst/>
+      </p:bgPr>
+    </p:bg>
+    <p:spTree>
+      <p:nvGrpSpPr>
+        <p:cNvPr id="1" name=""/>
+        <p:cNvGrpSpPr/>
+        <p:nvPr/>
+      </p:nvGrpSpPr>
+      <p:grpSpPr>
+        <a:xfrm>
+          <a:off x="0" y="0"/>
+          <a:ext cx="0" cy="0"/>
+          <a:chOff x="0" y="0"/>
+          <a:chExt cx="0" cy="0"/>
+        </a:xfrm>
+      </p:grpSpPr>
+      <p:sp>
+        <p:nvSpPr>
+          <p:cNvPr id="2" name="Title"/>
+          <p:cNvSpPr/>
+          <p:nvPr>
+            <p:ph type="title"/>
+          </p:nvPr>
+        </p:nvSpPr>
+        <p:spPr>
+          <a:xfrm>
+            <a:off x="548640" y="320040"/>
+            <a:ext cx="11094415" cy="1097280"/>
+          </a:xfrm>
+          <a:prstGeom prst="rect">
+            <a:avLst/>
+          </a:prstGeom>
+          <a:noFill/>
+          <a:ln>
+            <a:noFill/>
+          </a:ln>
+        </p:spPr>
+        <p:txBody>
+          <a:bodyPr wrap="square" lIns="45720" tIns="22860" rIns="45720" bIns="22860" anchor="ctr" rtlCol="0">
+            <a:noAutofit/>
+          </a:bodyPr>
+          <a:lstStyle/>
+          <a:p>
+            <a:pPr algn="l">
+              <a:lnSpc>
+                <a:spcPct val="100000"/>
+              </a:lnSpc>
+              <a:spcAft>
+                <a:spcPts val="600"/>
+              </a:spcAft>
+              <a:buNone/>
+            </a:pPr>
+            <a:r>
+              <a:rPr lang="en-GB" sz="3200" b="1" i="0" dirty="0">
+                <a:solidFill>
+                  <a:srgbClr val="1F2A44"/>
+                </a:solidFill>
+                <a:latin typeface="Arial"/>
+                <a:cs typeface="Arial"/>
+              </a:rPr>
+              <a:t>Backup: budget at a glance</a:t>
+            </a:r>
+            <a:endParaRPr lang="en-GB" sz="3200"/>
+          </a:p>
+        </p:txBody>
+      </p:sp>
+      <p:sp>
+        <p:nvSpPr>
+          <p:cNvPr id="3" name="Shape 3"/>
+          <p:cNvSpPr/>
+          <p:nvPr/>
+        </p:nvSpPr>
+        <p:spPr>
+          <a:xfrm>
+            <a:off x="10911535" y="6382512"/>
+            <a:ext cx="731520" cy="329184"/>
+          </a:xfrm>
+          <a:prstGeom prst="rect">
+            <a:avLst/>
+          </a:prstGeom>
+          <a:noFill/>
+          <a:ln>
+            <a:noFill/>
+          </a:ln>
+        </p:spPr>
+        <p:txBody>
+          <a:bodyPr wrap="square" lIns="0" tIns="0" rIns="0" bIns="0" anchor="t" rtlCol="0">
+            <a:noAutofit/>
+          </a:bodyPr>
+          <a:lstStyle/>
+          <a:p>
+            <a:pPr algn="r">
+              <a:lnSpc>
+                <a:spcPct val="100000"/>
+              </a:lnSpc>
+              <a:spcAft>
+                <a:spcPts val="600"/>
+              </a:spcAft>
+              <a:buNone/>
+            </a:pPr>
+            <a:r>
+              <a:rPr lang="en-GB" sz="1400" b="0" i="0" dirty="0">
+                <a:solidFill>
+                  <a:srgbClr val="5F6B7A"/>
+                </a:solidFill>
+                <a:latin typeface="Arial"/>
+                <a:cs typeface="Arial"/>
+              </a:rPr>
+              <a:t>21</a:t>
             </a:r>
             <a:endParaRPr lang="en-GB" sz="1400"/>
           </a:p>

</xml_diff>